<commit_message>
updates for fall 2026 (#30)
</commit_message>
<xml_diff>
--- a/logging_in_and_linux/logging_in_linux.pptx
+++ b/logging_in_and_linux/logging_in_linux.pptx
@@ -44,7 +44,7 @@
   <p:notesSz cx="6858000" cy="9144000"/>
   <p:embeddedFontLst>
     <p:embeddedFont>
-      <p:font typeface="Arial Black" panose="020B0604020202020204" pitchFamily="34" charset="0"/>
+      <p:font typeface="Arial Black" panose="020B0A04020102020204" pitchFamily="34" charset="0"/>
       <p:regular r:id="rId37"/>
       <p:bold r:id="rId38"/>
     </p:embeddedFont>
@@ -70,7 +70,7 @@
       <p:boldItalic r:id="rId50"/>
     </p:embeddedFont>
     <p:embeddedFont>
-      <p:font typeface="Helvetica Neue Light" panose="02000403000000020004" pitchFamily="2" charset="0"/>
+      <p:font typeface="Helvetica Neue Light" panose="020B0604020202020204" charset="0"/>
       <p:regular r:id="rId51"/>
       <p:bold r:id="rId52"/>
       <p:italic r:id="rId53"/>
@@ -91,7 +91,7 @@
       <p:boldItalic r:id="rId62"/>
     </p:embeddedFont>
     <p:embeddedFont>
-      <p:font typeface="Source Sans Pro Light" panose="020F0302020204030204" pitchFamily="34" charset="0"/>
+      <p:font typeface="Source Sans Pro Light" panose="020B0403030403020204" pitchFamily="34" charset="0"/>
       <p:regular r:id="rId63"/>
       <p:italic r:id="rId64"/>
     </p:embeddedFont>
@@ -14612,7 +14612,7 @@
               <a:rPr lang="en-US" sz="2800" dirty="0">
                 <a:latin typeface="Century Gothic" panose="020B0502020202020204" pitchFamily="34" charset="0"/>
               </a:rPr>
-              <a:t>August 18, 2025</a:t>
+              <a:t>August 10, 2026</a:t>
             </a:r>
           </a:p>
         </p:txBody>
@@ -14649,7 +14649,7 @@
               <a:rPr lang="en-US" dirty="0">
                 <a:latin typeface="Century Gothic"/>
               </a:rPr>
-              <a:t>Andy Monaghan</a:t>
+              <a:t>Mohal Khandelwal</a:t>
             </a:r>
           </a:p>
           <a:p>
@@ -14661,35 +14661,6 @@
             <a:endParaRPr lang="en-US" dirty="0">
               <a:latin typeface="Century Gothic" panose="020B0502020202020204" pitchFamily="34" charset="0"/>
             </a:endParaRPr>
-          </a:p>
-        </p:txBody>
-      </p:sp>
-      <p:sp>
-        <p:nvSpPr>
-          <p:cNvPr id="5" name="Date Placeholder 4">
-            <a:extLst>
-              <a:ext uri="{FF2B5EF4-FFF2-40B4-BE49-F238E27FC236}">
-                <a16:creationId xmlns:a16="http://schemas.microsoft.com/office/drawing/2014/main" id="{AA80CDA0-0468-B8AD-0274-1C864E71D4F1}"/>
-              </a:ext>
-            </a:extLst>
-          </p:cNvPr>
-          <p:cNvSpPr>
-            <a:spLocks noGrp="1"/>
-          </p:cNvSpPr>
-          <p:nvPr>
-            <p:ph type="dt" idx="10"/>
-          </p:nvPr>
-        </p:nvSpPr>
-        <p:spPr/>
-        <p:txBody>
-          <a:bodyPr/>
-          <a:lstStyle/>
-          <a:p>
-            <a:r>
-              <a:rPr lang="en-US"/>
-              <a:t>8/18/25</a:t>
-            </a:r>
-            <a:endParaRPr lang="en-US" dirty="0"/>
           </a:p>
         </p:txBody>
       </p:sp>
@@ -14824,34 +14795,6 @@
               <a:t>10</a:t>
             </a:fld>
             <a:endParaRPr lang="en-US"/>
-          </a:p>
-        </p:txBody>
-      </p:sp>
-      <p:sp>
-        <p:nvSpPr>
-          <p:cNvPr id="2" name="Date Placeholder 1">
-            <a:extLst>
-              <a:ext uri="{FF2B5EF4-FFF2-40B4-BE49-F238E27FC236}">
-                <a16:creationId xmlns:a16="http://schemas.microsoft.com/office/drawing/2014/main" id="{A1D5468F-ED2A-D72A-0BF9-6CC9E5099FEC}"/>
-              </a:ext>
-            </a:extLst>
-          </p:cNvPr>
-          <p:cNvSpPr>
-            <a:spLocks noGrp="1"/>
-          </p:cNvSpPr>
-          <p:nvPr>
-            <p:ph type="dt" idx="10"/>
-          </p:nvPr>
-        </p:nvSpPr>
-        <p:spPr/>
-        <p:txBody>
-          <a:bodyPr/>
-          <a:lstStyle/>
-          <a:p>
-            <a:r>
-              <a:rPr lang="en-US"/>
-              <a:t>8/18/25</a:t>
-            </a:r>
           </a:p>
         </p:txBody>
       </p:sp>
@@ -15145,34 +15088,6 @@
           </a:p>
         </p:txBody>
       </p:sp>
-      <p:sp>
-        <p:nvSpPr>
-          <p:cNvPr id="2" name="Date Placeholder 1">
-            <a:extLst>
-              <a:ext uri="{FF2B5EF4-FFF2-40B4-BE49-F238E27FC236}">
-                <a16:creationId xmlns:a16="http://schemas.microsoft.com/office/drawing/2014/main" id="{264A22E2-99E3-ED58-8310-374690D286F0}"/>
-              </a:ext>
-            </a:extLst>
-          </p:cNvPr>
-          <p:cNvSpPr>
-            <a:spLocks noGrp="1"/>
-          </p:cNvSpPr>
-          <p:nvPr>
-            <p:ph type="dt" idx="10"/>
-          </p:nvPr>
-        </p:nvSpPr>
-        <p:spPr/>
-        <p:txBody>
-          <a:bodyPr/>
-          <a:lstStyle/>
-          <a:p>
-            <a:r>
-              <a:rPr lang="en-US"/>
-              <a:t>8/18/25</a:t>
-            </a:r>
-          </a:p>
-        </p:txBody>
-      </p:sp>
       <p:pic>
         <p:nvPicPr>
           <p:cNvPr id="14" name="Picture 13" descr="Image showing directories available to each user, including the home, projects, scratch, and petalibrary directories.">
@@ -15762,34 +15677,6 @@
       </p:sp>
       <p:sp>
         <p:nvSpPr>
-          <p:cNvPr id="2" name="Date Placeholder 1">
-            <a:extLst>
-              <a:ext uri="{FF2B5EF4-FFF2-40B4-BE49-F238E27FC236}">
-                <a16:creationId xmlns:a16="http://schemas.microsoft.com/office/drawing/2014/main" id="{3E6D2F89-15E6-FF1D-DF85-4959701B6EB4}"/>
-              </a:ext>
-            </a:extLst>
-          </p:cNvPr>
-          <p:cNvSpPr>
-            <a:spLocks noGrp="1"/>
-          </p:cNvSpPr>
-          <p:nvPr>
-            <p:ph type="dt" idx="10"/>
-          </p:nvPr>
-        </p:nvSpPr>
-        <p:spPr/>
-        <p:txBody>
-          <a:bodyPr/>
-          <a:lstStyle/>
-          <a:p>
-            <a:r>
-              <a:rPr lang="en-US"/>
-              <a:t>8/18/25</a:t>
-            </a:r>
-          </a:p>
-        </p:txBody>
-      </p:sp>
-      <p:sp>
-        <p:nvSpPr>
           <p:cNvPr id="4" name="Footer Placeholder 3">
             <a:extLst>
               <a:ext uri="{FF2B5EF4-FFF2-40B4-BE49-F238E27FC236}">
@@ -16085,34 +15972,6 @@
       </p:sp>
       <p:sp>
         <p:nvSpPr>
-          <p:cNvPr id="2" name="Date Placeholder 1">
-            <a:extLst>
-              <a:ext uri="{FF2B5EF4-FFF2-40B4-BE49-F238E27FC236}">
-                <a16:creationId xmlns:a16="http://schemas.microsoft.com/office/drawing/2014/main" id="{5D3BFA8F-ABA2-5C88-ACD0-48CC11E344A3}"/>
-              </a:ext>
-            </a:extLst>
-          </p:cNvPr>
-          <p:cNvSpPr>
-            <a:spLocks noGrp="1"/>
-          </p:cNvSpPr>
-          <p:nvPr>
-            <p:ph type="dt" idx="10"/>
-          </p:nvPr>
-        </p:nvSpPr>
-        <p:spPr/>
-        <p:txBody>
-          <a:bodyPr/>
-          <a:lstStyle/>
-          <a:p>
-            <a:r>
-              <a:rPr lang="en-US"/>
-              <a:t>8/18/25</a:t>
-            </a:r>
-          </a:p>
-        </p:txBody>
-      </p:sp>
-      <p:sp>
-        <p:nvSpPr>
           <p:cNvPr id="4" name="Footer Placeholder 3">
             <a:extLst>
               <a:ext uri="{FF2B5EF4-FFF2-40B4-BE49-F238E27FC236}">
@@ -16489,34 +16348,6 @@
       </p:sp>
       <p:sp>
         <p:nvSpPr>
-          <p:cNvPr id="2" name="Date Placeholder 1">
-            <a:extLst>
-              <a:ext uri="{FF2B5EF4-FFF2-40B4-BE49-F238E27FC236}">
-                <a16:creationId xmlns:a16="http://schemas.microsoft.com/office/drawing/2014/main" id="{A66ACFDB-AB94-5743-B381-4885432DAB0A}"/>
-              </a:ext>
-            </a:extLst>
-          </p:cNvPr>
-          <p:cNvSpPr>
-            <a:spLocks noGrp="1"/>
-          </p:cNvSpPr>
-          <p:nvPr>
-            <p:ph type="dt" idx="10"/>
-          </p:nvPr>
-        </p:nvSpPr>
-        <p:spPr/>
-        <p:txBody>
-          <a:bodyPr/>
-          <a:lstStyle/>
-          <a:p>
-            <a:r>
-              <a:rPr lang="en-US"/>
-              <a:t>8/18/25</a:t>
-            </a:r>
-          </a:p>
-        </p:txBody>
-      </p:sp>
-      <p:sp>
-        <p:nvSpPr>
           <p:cNvPr id="4" name="Footer Placeholder 3">
             <a:extLst>
               <a:ext uri="{FF2B5EF4-FFF2-40B4-BE49-F238E27FC236}">
@@ -16897,34 +16728,6 @@
       </p:sp>
       <p:sp>
         <p:nvSpPr>
-          <p:cNvPr id="2" name="Date Placeholder 1">
-            <a:extLst>
-              <a:ext uri="{FF2B5EF4-FFF2-40B4-BE49-F238E27FC236}">
-                <a16:creationId xmlns:a16="http://schemas.microsoft.com/office/drawing/2014/main" id="{3C70CD93-89FC-3A2A-105D-77A6C4E09046}"/>
-              </a:ext>
-            </a:extLst>
-          </p:cNvPr>
-          <p:cNvSpPr>
-            <a:spLocks noGrp="1"/>
-          </p:cNvSpPr>
-          <p:nvPr>
-            <p:ph type="dt" idx="10"/>
-          </p:nvPr>
-        </p:nvSpPr>
-        <p:spPr/>
-        <p:txBody>
-          <a:bodyPr/>
-          <a:lstStyle/>
-          <a:p>
-            <a:r>
-              <a:rPr lang="en-US"/>
-              <a:t>8/18/25</a:t>
-            </a:r>
-          </a:p>
-        </p:txBody>
-      </p:sp>
-      <p:sp>
-        <p:nvSpPr>
           <p:cNvPr id="4" name="Footer Placeholder 3">
             <a:extLst>
               <a:ext uri="{FF2B5EF4-FFF2-40B4-BE49-F238E27FC236}">
@@ -17346,34 +17149,6 @@
       </p:sp>
       <p:sp>
         <p:nvSpPr>
-          <p:cNvPr id="2" name="Date Placeholder 1">
-            <a:extLst>
-              <a:ext uri="{FF2B5EF4-FFF2-40B4-BE49-F238E27FC236}">
-                <a16:creationId xmlns:a16="http://schemas.microsoft.com/office/drawing/2014/main" id="{034D9E5E-61E8-04DC-BC8F-DC76583D26FC}"/>
-              </a:ext>
-            </a:extLst>
-          </p:cNvPr>
-          <p:cNvSpPr>
-            <a:spLocks noGrp="1"/>
-          </p:cNvSpPr>
-          <p:nvPr>
-            <p:ph type="dt" idx="10"/>
-          </p:nvPr>
-        </p:nvSpPr>
-        <p:spPr/>
-        <p:txBody>
-          <a:bodyPr/>
-          <a:lstStyle/>
-          <a:p>
-            <a:r>
-              <a:rPr lang="en-US"/>
-              <a:t>8/18/25</a:t>
-            </a:r>
-          </a:p>
-        </p:txBody>
-      </p:sp>
-      <p:sp>
-        <p:nvSpPr>
           <p:cNvPr id="4" name="Footer Placeholder 3">
             <a:extLst>
               <a:ext uri="{FF2B5EF4-FFF2-40B4-BE49-F238E27FC236}">
@@ -17854,34 +17629,6 @@
       </p:cxnSp>
       <p:sp>
         <p:nvSpPr>
-          <p:cNvPr id="2" name="Date Placeholder 1">
-            <a:extLst>
-              <a:ext uri="{FF2B5EF4-FFF2-40B4-BE49-F238E27FC236}">
-                <a16:creationId xmlns:a16="http://schemas.microsoft.com/office/drawing/2014/main" id="{38905E70-90B1-FAA8-4532-977ED228489F}"/>
-              </a:ext>
-            </a:extLst>
-          </p:cNvPr>
-          <p:cNvSpPr>
-            <a:spLocks noGrp="1"/>
-          </p:cNvSpPr>
-          <p:nvPr>
-            <p:ph type="dt" idx="10"/>
-          </p:nvPr>
-        </p:nvSpPr>
-        <p:spPr/>
-        <p:txBody>
-          <a:bodyPr/>
-          <a:lstStyle/>
-          <a:p>
-            <a:r>
-              <a:rPr lang="en-US"/>
-              <a:t>8/18/25</a:t>
-            </a:r>
-          </a:p>
-        </p:txBody>
-      </p:sp>
-      <p:sp>
-        <p:nvSpPr>
           <p:cNvPr id="5" name="Footer Placeholder 4">
             <a:extLst>
               <a:ext uri="{FF2B5EF4-FFF2-40B4-BE49-F238E27FC236}">
@@ -18254,34 +18001,6 @@
       </p:sp>
       <p:sp>
         <p:nvSpPr>
-          <p:cNvPr id="2" name="Date Placeholder 1">
-            <a:extLst>
-              <a:ext uri="{FF2B5EF4-FFF2-40B4-BE49-F238E27FC236}">
-                <a16:creationId xmlns:a16="http://schemas.microsoft.com/office/drawing/2014/main" id="{50E2D313-F58F-929E-3CBD-6962D2014D65}"/>
-              </a:ext>
-            </a:extLst>
-          </p:cNvPr>
-          <p:cNvSpPr>
-            <a:spLocks noGrp="1"/>
-          </p:cNvSpPr>
-          <p:nvPr>
-            <p:ph type="dt" idx="10"/>
-          </p:nvPr>
-        </p:nvSpPr>
-        <p:spPr/>
-        <p:txBody>
-          <a:bodyPr/>
-          <a:lstStyle/>
-          <a:p>
-            <a:r>
-              <a:rPr lang="en-US"/>
-              <a:t>8/18/25</a:t>
-            </a:r>
-          </a:p>
-        </p:txBody>
-      </p:sp>
-      <p:sp>
-        <p:nvSpPr>
           <p:cNvPr id="3" name="Slide Number Placeholder 2">
             <a:extLst>
               <a:ext uri="{FF2B5EF4-FFF2-40B4-BE49-F238E27FC236}">
@@ -18662,34 +18381,6 @@
       </p:sp>
       <p:sp>
         <p:nvSpPr>
-          <p:cNvPr id="2" name="Date Placeholder 1">
-            <a:extLst>
-              <a:ext uri="{FF2B5EF4-FFF2-40B4-BE49-F238E27FC236}">
-                <a16:creationId xmlns:a16="http://schemas.microsoft.com/office/drawing/2014/main" id="{BDA7BF76-3D50-2824-E739-82DCC8A94A93}"/>
-              </a:ext>
-            </a:extLst>
-          </p:cNvPr>
-          <p:cNvSpPr>
-            <a:spLocks noGrp="1"/>
-          </p:cNvSpPr>
-          <p:nvPr>
-            <p:ph type="dt" idx="10"/>
-          </p:nvPr>
-        </p:nvSpPr>
-        <p:spPr/>
-        <p:txBody>
-          <a:bodyPr/>
-          <a:lstStyle/>
-          <a:p>
-            <a:r>
-              <a:rPr lang="en-US"/>
-              <a:t>8/18/25</a:t>
-            </a:r>
-          </a:p>
-        </p:txBody>
-      </p:sp>
-      <p:sp>
-        <p:nvSpPr>
           <p:cNvPr id="4" name="Footer Placeholder 3">
             <a:extLst>
               <a:ext uri="{FF2B5EF4-FFF2-40B4-BE49-F238E27FC236}">
@@ -18972,34 +18663,6 @@
       </p:sp>
       <p:sp>
         <p:nvSpPr>
-          <p:cNvPr id="2" name="Date Placeholder 1">
-            <a:extLst>
-              <a:ext uri="{FF2B5EF4-FFF2-40B4-BE49-F238E27FC236}">
-                <a16:creationId xmlns:a16="http://schemas.microsoft.com/office/drawing/2014/main" id="{D0945F04-8548-1058-D4BF-305D16439301}"/>
-              </a:ext>
-            </a:extLst>
-          </p:cNvPr>
-          <p:cNvSpPr>
-            <a:spLocks noGrp="1"/>
-          </p:cNvSpPr>
-          <p:nvPr>
-            <p:ph type="dt" idx="10"/>
-          </p:nvPr>
-        </p:nvSpPr>
-        <p:spPr/>
-        <p:txBody>
-          <a:bodyPr/>
-          <a:lstStyle/>
-          <a:p>
-            <a:r>
-              <a:rPr lang="en-US"/>
-              <a:t>8/18/25</a:t>
-            </a:r>
-          </a:p>
-        </p:txBody>
-      </p:sp>
-      <p:sp>
-        <p:nvSpPr>
           <p:cNvPr id="3" name="Footer Placeholder 2">
             <a:extLst>
               <a:ext uri="{FF2B5EF4-FFF2-40B4-BE49-F238E27FC236}">
@@ -19362,34 +19025,6 @@
               <a:t>20</a:t>
             </a:fld>
             <a:endParaRPr lang="en-US"/>
-          </a:p>
-        </p:txBody>
-      </p:sp>
-      <p:sp>
-        <p:nvSpPr>
-          <p:cNvPr id="2" name="Date Placeholder 1">
-            <a:extLst>
-              <a:ext uri="{FF2B5EF4-FFF2-40B4-BE49-F238E27FC236}">
-                <a16:creationId xmlns:a16="http://schemas.microsoft.com/office/drawing/2014/main" id="{FFB53CF0-2012-8E08-BA34-CB50B2F6CDBA}"/>
-              </a:ext>
-            </a:extLst>
-          </p:cNvPr>
-          <p:cNvSpPr>
-            <a:spLocks noGrp="1"/>
-          </p:cNvSpPr>
-          <p:nvPr>
-            <p:ph type="dt" idx="10"/>
-          </p:nvPr>
-        </p:nvSpPr>
-        <p:spPr/>
-        <p:txBody>
-          <a:bodyPr/>
-          <a:lstStyle/>
-          <a:p>
-            <a:r>
-              <a:rPr lang="en-US"/>
-              <a:t>8/18/25</a:t>
-            </a:r>
           </a:p>
         </p:txBody>
       </p:sp>
@@ -19767,34 +19402,6 @@
       </p:sp>
       <p:sp>
         <p:nvSpPr>
-          <p:cNvPr id="2" name="Date Placeholder 1">
-            <a:extLst>
-              <a:ext uri="{FF2B5EF4-FFF2-40B4-BE49-F238E27FC236}">
-                <a16:creationId xmlns:a16="http://schemas.microsoft.com/office/drawing/2014/main" id="{68956538-AE96-2E09-AF05-B2BC5C3FAEA0}"/>
-              </a:ext>
-            </a:extLst>
-          </p:cNvPr>
-          <p:cNvSpPr>
-            <a:spLocks noGrp="1"/>
-          </p:cNvSpPr>
-          <p:nvPr>
-            <p:ph type="dt" idx="10"/>
-          </p:nvPr>
-        </p:nvSpPr>
-        <p:spPr/>
-        <p:txBody>
-          <a:bodyPr/>
-          <a:lstStyle/>
-          <a:p>
-            <a:r>
-              <a:rPr lang="en-US"/>
-              <a:t>8/18/25</a:t>
-            </a:r>
-          </a:p>
-        </p:txBody>
-      </p:sp>
-      <p:sp>
-        <p:nvSpPr>
           <p:cNvPr id="4" name="Footer Placeholder 3">
             <a:extLst>
               <a:ext uri="{FF2B5EF4-FFF2-40B4-BE49-F238E27FC236}">
@@ -20361,34 +19968,6 @@
               <a:cs typeface="Georgia"/>
               <a:sym typeface="Georgia"/>
             </a:endParaRPr>
-          </a:p>
-        </p:txBody>
-      </p:sp>
-      <p:sp>
-        <p:nvSpPr>
-          <p:cNvPr id="2" name="Date Placeholder 1">
-            <a:extLst>
-              <a:ext uri="{FF2B5EF4-FFF2-40B4-BE49-F238E27FC236}">
-                <a16:creationId xmlns:a16="http://schemas.microsoft.com/office/drawing/2014/main" id="{4246D59B-909D-F90E-82C1-C920E397C127}"/>
-              </a:ext>
-            </a:extLst>
-          </p:cNvPr>
-          <p:cNvSpPr>
-            <a:spLocks noGrp="1"/>
-          </p:cNvSpPr>
-          <p:nvPr>
-            <p:ph type="dt" idx="10"/>
-          </p:nvPr>
-        </p:nvSpPr>
-        <p:spPr/>
-        <p:txBody>
-          <a:bodyPr/>
-          <a:lstStyle/>
-          <a:p>
-            <a:r>
-              <a:rPr lang="en-US"/>
-              <a:t>8/18/25</a:t>
-            </a:r>
           </a:p>
         </p:txBody>
       </p:sp>
@@ -21185,34 +20764,6 @@
       </p:sp>
       <p:sp>
         <p:nvSpPr>
-          <p:cNvPr id="2" name="Date Placeholder 1">
-            <a:extLst>
-              <a:ext uri="{FF2B5EF4-FFF2-40B4-BE49-F238E27FC236}">
-                <a16:creationId xmlns:a16="http://schemas.microsoft.com/office/drawing/2014/main" id="{79F72456-FB22-4CA7-D7BC-DC61F8629DFE}"/>
-              </a:ext>
-            </a:extLst>
-          </p:cNvPr>
-          <p:cNvSpPr>
-            <a:spLocks noGrp="1"/>
-          </p:cNvSpPr>
-          <p:nvPr>
-            <p:ph type="dt" idx="10"/>
-          </p:nvPr>
-        </p:nvSpPr>
-        <p:spPr/>
-        <p:txBody>
-          <a:bodyPr/>
-          <a:lstStyle/>
-          <a:p>
-            <a:r>
-              <a:rPr lang="en-US"/>
-              <a:t>8/18/25</a:t>
-            </a:r>
-          </a:p>
-        </p:txBody>
-      </p:sp>
-      <p:sp>
-        <p:nvSpPr>
           <p:cNvPr id="5" name="Slide Number Placeholder 4">
             <a:extLst>
               <a:ext uri="{FF2B5EF4-FFF2-40B4-BE49-F238E27FC236}">
@@ -21874,34 +21425,6 @@
       </p:sp>
       <p:sp>
         <p:nvSpPr>
-          <p:cNvPr id="2" name="Date Placeholder 1">
-            <a:extLst>
-              <a:ext uri="{FF2B5EF4-FFF2-40B4-BE49-F238E27FC236}">
-                <a16:creationId xmlns:a16="http://schemas.microsoft.com/office/drawing/2014/main" id="{944D9B3D-FF23-F250-0EC4-789CA03A40D9}"/>
-              </a:ext>
-            </a:extLst>
-          </p:cNvPr>
-          <p:cNvSpPr>
-            <a:spLocks noGrp="1"/>
-          </p:cNvSpPr>
-          <p:nvPr>
-            <p:ph type="dt" idx="10"/>
-          </p:nvPr>
-        </p:nvSpPr>
-        <p:spPr/>
-        <p:txBody>
-          <a:bodyPr/>
-          <a:lstStyle/>
-          <a:p>
-            <a:r>
-              <a:rPr lang="en-US"/>
-              <a:t>8/18/25</a:t>
-            </a:r>
-          </a:p>
-        </p:txBody>
-      </p:sp>
-      <p:sp>
-        <p:nvSpPr>
           <p:cNvPr id="4" name="Slide Number Placeholder 3">
             <a:extLst>
               <a:ext uri="{FF2B5EF4-FFF2-40B4-BE49-F238E27FC236}">
@@ -22662,34 +22185,6 @@
           </a:prstGeom>
         </p:spPr>
       </p:pic>
-      <p:sp>
-        <p:nvSpPr>
-          <p:cNvPr id="2" name="Date Placeholder 1">
-            <a:extLst>
-              <a:ext uri="{FF2B5EF4-FFF2-40B4-BE49-F238E27FC236}">
-                <a16:creationId xmlns:a16="http://schemas.microsoft.com/office/drawing/2014/main" id="{7364C0E2-0B28-FFD0-36EC-842103769E06}"/>
-              </a:ext>
-            </a:extLst>
-          </p:cNvPr>
-          <p:cNvSpPr>
-            <a:spLocks noGrp="1"/>
-          </p:cNvSpPr>
-          <p:nvPr>
-            <p:ph type="dt" idx="10"/>
-          </p:nvPr>
-        </p:nvSpPr>
-        <p:spPr/>
-        <p:txBody>
-          <a:bodyPr/>
-          <a:lstStyle/>
-          <a:p>
-            <a:r>
-              <a:rPr lang="en-US"/>
-              <a:t>8/18/25</a:t>
-            </a:r>
-          </a:p>
-        </p:txBody>
-      </p:sp>
       <p:sp>
         <p:nvSpPr>
           <p:cNvPr id="4" name="Footer Placeholder 3">
@@ -23205,34 +22700,6 @@
       </p:sp>
       <p:sp>
         <p:nvSpPr>
-          <p:cNvPr id="2" name="Date Placeholder 1">
-            <a:extLst>
-              <a:ext uri="{FF2B5EF4-FFF2-40B4-BE49-F238E27FC236}">
-                <a16:creationId xmlns:a16="http://schemas.microsoft.com/office/drawing/2014/main" id="{C8C83662-21CF-831A-3850-E8447B61036F}"/>
-              </a:ext>
-            </a:extLst>
-          </p:cNvPr>
-          <p:cNvSpPr>
-            <a:spLocks noGrp="1"/>
-          </p:cNvSpPr>
-          <p:nvPr>
-            <p:ph type="dt" idx="10"/>
-          </p:nvPr>
-        </p:nvSpPr>
-        <p:spPr/>
-        <p:txBody>
-          <a:bodyPr/>
-          <a:lstStyle/>
-          <a:p>
-            <a:r>
-              <a:rPr lang="en-US"/>
-              <a:t>8/18/25</a:t>
-            </a:r>
-          </a:p>
-        </p:txBody>
-      </p:sp>
-      <p:sp>
-        <p:nvSpPr>
           <p:cNvPr id="4" name="Footer Placeholder 3">
             <a:extLst>
               <a:ext uri="{FF2B5EF4-FFF2-40B4-BE49-F238E27FC236}">
@@ -23612,34 +23079,6 @@
       </p:sp>
       <p:sp>
         <p:nvSpPr>
-          <p:cNvPr id="3" name="Date Placeholder 2">
-            <a:extLst>
-              <a:ext uri="{FF2B5EF4-FFF2-40B4-BE49-F238E27FC236}">
-                <a16:creationId xmlns:a16="http://schemas.microsoft.com/office/drawing/2014/main" id="{9B003E57-FAFA-7DCD-147B-CC2D5108A436}"/>
-              </a:ext>
-            </a:extLst>
-          </p:cNvPr>
-          <p:cNvSpPr>
-            <a:spLocks noGrp="1"/>
-          </p:cNvSpPr>
-          <p:nvPr>
-            <p:ph type="dt" idx="10"/>
-          </p:nvPr>
-        </p:nvSpPr>
-        <p:spPr/>
-        <p:txBody>
-          <a:bodyPr/>
-          <a:lstStyle/>
-          <a:p>
-            <a:r>
-              <a:rPr lang="en-US"/>
-              <a:t>8/18/25</a:t>
-            </a:r>
-          </a:p>
-        </p:txBody>
-      </p:sp>
-      <p:sp>
-        <p:nvSpPr>
           <p:cNvPr id="4" name="Footer Placeholder 3">
             <a:extLst>
               <a:ext uri="{FF2B5EF4-FFF2-40B4-BE49-F238E27FC236}">
@@ -23949,34 +23388,6 @@
               <a:t>28</a:t>
             </a:fld>
             <a:endParaRPr lang="en-US"/>
-          </a:p>
-        </p:txBody>
-      </p:sp>
-      <p:sp>
-        <p:nvSpPr>
-          <p:cNvPr id="3" name="Date Placeholder 2">
-            <a:extLst>
-              <a:ext uri="{FF2B5EF4-FFF2-40B4-BE49-F238E27FC236}">
-                <a16:creationId xmlns:a16="http://schemas.microsoft.com/office/drawing/2014/main" id="{03E14D24-FDC7-7225-FB93-6F7DD09EDC16}"/>
-              </a:ext>
-            </a:extLst>
-          </p:cNvPr>
-          <p:cNvSpPr>
-            <a:spLocks noGrp="1"/>
-          </p:cNvSpPr>
-          <p:nvPr>
-            <p:ph type="dt" idx="10"/>
-          </p:nvPr>
-        </p:nvSpPr>
-        <p:spPr/>
-        <p:txBody>
-          <a:bodyPr/>
-          <a:lstStyle/>
-          <a:p>
-            <a:r>
-              <a:rPr lang="en-US" dirty="0"/>
-              <a:t>8/18/25</a:t>
-            </a:r>
           </a:p>
         </p:txBody>
       </p:sp>
@@ -24526,34 +23937,6 @@
               <a:cs typeface="Courier New"/>
               <a:sym typeface="Courier New"/>
             </a:endParaRPr>
-          </a:p>
-        </p:txBody>
-      </p:sp>
-      <p:sp>
-        <p:nvSpPr>
-          <p:cNvPr id="2" name="Date Placeholder 1">
-            <a:extLst>
-              <a:ext uri="{FF2B5EF4-FFF2-40B4-BE49-F238E27FC236}">
-                <a16:creationId xmlns:a16="http://schemas.microsoft.com/office/drawing/2014/main" id="{85AE7D93-15F8-7DFC-C1AB-82B475225D55}"/>
-              </a:ext>
-            </a:extLst>
-          </p:cNvPr>
-          <p:cNvSpPr>
-            <a:spLocks noGrp="1"/>
-          </p:cNvSpPr>
-          <p:nvPr>
-            <p:ph type="dt" idx="10"/>
-          </p:nvPr>
-        </p:nvSpPr>
-        <p:spPr/>
-        <p:txBody>
-          <a:bodyPr/>
-          <a:lstStyle/>
-          <a:p>
-            <a:r>
-              <a:rPr lang="en-US"/>
-              <a:t>8/18/25</a:t>
-            </a:r>
           </a:p>
         </p:txBody>
       </p:sp>
@@ -25362,34 +24745,6 @@
       </p:sp>
       <p:sp>
         <p:nvSpPr>
-          <p:cNvPr id="2" name="Date Placeholder 1">
-            <a:extLst>
-              <a:ext uri="{FF2B5EF4-FFF2-40B4-BE49-F238E27FC236}">
-                <a16:creationId xmlns:a16="http://schemas.microsoft.com/office/drawing/2014/main" id="{1072592F-33FA-0B33-1988-CEB17D17EB85}"/>
-              </a:ext>
-            </a:extLst>
-          </p:cNvPr>
-          <p:cNvSpPr>
-            <a:spLocks noGrp="1"/>
-          </p:cNvSpPr>
-          <p:nvPr>
-            <p:ph type="dt" idx="10"/>
-          </p:nvPr>
-        </p:nvSpPr>
-        <p:spPr/>
-        <p:txBody>
-          <a:bodyPr/>
-          <a:lstStyle/>
-          <a:p>
-            <a:r>
-              <a:rPr lang="en-US"/>
-              <a:t>8/18/25</a:t>
-            </a:r>
-          </a:p>
-        </p:txBody>
-      </p:sp>
-      <p:sp>
-        <p:nvSpPr>
           <p:cNvPr id="4" name="Footer Placeholder 3">
             <a:extLst>
               <a:ext uri="{FF2B5EF4-FFF2-40B4-BE49-F238E27FC236}">
@@ -26034,34 +25389,6 @@
               <a:t>30</a:t>
             </a:fld>
             <a:endParaRPr lang="en-US"/>
-          </a:p>
-        </p:txBody>
-      </p:sp>
-      <p:sp>
-        <p:nvSpPr>
-          <p:cNvPr id="2" name="Date Placeholder 1">
-            <a:extLst>
-              <a:ext uri="{FF2B5EF4-FFF2-40B4-BE49-F238E27FC236}">
-                <a16:creationId xmlns:a16="http://schemas.microsoft.com/office/drawing/2014/main" id="{BED54731-DDC8-B23A-8E2C-D8E423990E2C}"/>
-              </a:ext>
-            </a:extLst>
-          </p:cNvPr>
-          <p:cNvSpPr>
-            <a:spLocks noGrp="1"/>
-          </p:cNvSpPr>
-          <p:nvPr>
-            <p:ph type="dt" idx="10"/>
-          </p:nvPr>
-        </p:nvSpPr>
-        <p:spPr/>
-        <p:txBody>
-          <a:bodyPr/>
-          <a:lstStyle/>
-          <a:p>
-            <a:r>
-              <a:rPr lang="en-US"/>
-              <a:t>8/18/25</a:t>
-            </a:r>
           </a:p>
         </p:txBody>
       </p:sp>
@@ -26240,39 +25567,6 @@
           </a:p>
         </p:txBody>
       </p:sp>
-      <p:sp>
-        <p:nvSpPr>
-          <p:cNvPr id="4" name="Date Placeholder 2">
-            <a:extLst>
-              <a:ext uri="{FF2B5EF4-FFF2-40B4-BE49-F238E27FC236}">
-                <a16:creationId xmlns:a16="http://schemas.microsoft.com/office/drawing/2014/main" id="{6DA1E5D1-8D5E-CE4B-17BB-DBFF772E66E7}"/>
-              </a:ext>
-            </a:extLst>
-          </p:cNvPr>
-          <p:cNvSpPr>
-            <a:spLocks noGrp="1"/>
-          </p:cNvSpPr>
-          <p:nvPr>
-            <p:ph type="dt" idx="10"/>
-          </p:nvPr>
-        </p:nvSpPr>
-        <p:spPr>
-          <a:xfrm>
-            <a:off x="2931386" y="6356349"/>
-            <a:ext cx="906687" cy="327667"/>
-          </a:xfrm>
-        </p:spPr>
-        <p:txBody>
-          <a:bodyPr/>
-          <a:lstStyle/>
-          <a:p>
-            <a:r>
-              <a:rPr lang="en-US" dirty="0"/>
-              <a:t>1/29/2025</a:t>
-            </a:r>
-          </a:p>
-        </p:txBody>
-      </p:sp>
     </p:spTree>
   </p:cSld>
   <p:clrMapOvr>
@@ -26767,34 +26061,6 @@
           </a:extLst>
         </p:spPr>
       </p:pic>
-      <p:sp>
-        <p:nvSpPr>
-          <p:cNvPr id="2" name="Date Placeholder 1">
-            <a:extLst>
-              <a:ext uri="{FF2B5EF4-FFF2-40B4-BE49-F238E27FC236}">
-                <a16:creationId xmlns:a16="http://schemas.microsoft.com/office/drawing/2014/main" id="{2BE59917-9762-F27E-BF49-0A3C6DE88303}"/>
-              </a:ext>
-            </a:extLst>
-          </p:cNvPr>
-          <p:cNvSpPr>
-            <a:spLocks noGrp="1"/>
-          </p:cNvSpPr>
-          <p:nvPr>
-            <p:ph type="dt" idx="10"/>
-          </p:nvPr>
-        </p:nvSpPr>
-        <p:spPr/>
-        <p:txBody>
-          <a:bodyPr/>
-          <a:lstStyle/>
-          <a:p>
-            <a:r>
-              <a:rPr lang="en-US"/>
-              <a:t>8/18/25</a:t>
-            </a:r>
-          </a:p>
-        </p:txBody>
-      </p:sp>
       <p:sp>
         <p:nvSpPr>
           <p:cNvPr id="4" name="Footer Placeholder 3">
@@ -27293,34 +26559,6 @@
       </p:sp>
       <p:sp>
         <p:nvSpPr>
-          <p:cNvPr id="2" name="Date Placeholder 1">
-            <a:extLst>
-              <a:ext uri="{FF2B5EF4-FFF2-40B4-BE49-F238E27FC236}">
-                <a16:creationId xmlns:a16="http://schemas.microsoft.com/office/drawing/2014/main" id="{7A12B8D9-1EE5-346E-333B-3F1E1B94F553}"/>
-              </a:ext>
-            </a:extLst>
-          </p:cNvPr>
-          <p:cNvSpPr>
-            <a:spLocks noGrp="1"/>
-          </p:cNvSpPr>
-          <p:nvPr>
-            <p:ph type="dt" idx="10"/>
-          </p:nvPr>
-        </p:nvSpPr>
-        <p:spPr/>
-        <p:txBody>
-          <a:bodyPr/>
-          <a:lstStyle/>
-          <a:p>
-            <a:r>
-              <a:rPr lang="en-US"/>
-              <a:t>8/18/25</a:t>
-            </a:r>
-          </a:p>
-        </p:txBody>
-      </p:sp>
-      <p:sp>
-        <p:nvSpPr>
           <p:cNvPr id="5" name="Footer Placeholder 4">
             <a:extLst>
               <a:ext uri="{FF2B5EF4-FFF2-40B4-BE49-F238E27FC236}">
@@ -27940,34 +27178,6 @@
               <a:ea typeface="Helvetica Neue Light" panose="02000403000000020004" pitchFamily="2" charset="0"/>
               <a:sym typeface="Arial"/>
             </a:endParaRPr>
-          </a:p>
-        </p:txBody>
-      </p:sp>
-      <p:sp>
-        <p:nvSpPr>
-          <p:cNvPr id="2" name="Date Placeholder 1">
-            <a:extLst>
-              <a:ext uri="{FF2B5EF4-FFF2-40B4-BE49-F238E27FC236}">
-                <a16:creationId xmlns:a16="http://schemas.microsoft.com/office/drawing/2014/main" id="{868DFF11-AC27-489E-E1C4-E2349615B1AA}"/>
-              </a:ext>
-            </a:extLst>
-          </p:cNvPr>
-          <p:cNvSpPr>
-            <a:spLocks noGrp="1"/>
-          </p:cNvSpPr>
-          <p:nvPr>
-            <p:ph type="dt" idx="10"/>
-          </p:nvPr>
-        </p:nvSpPr>
-        <p:spPr/>
-        <p:txBody>
-          <a:bodyPr/>
-          <a:lstStyle/>
-          <a:p>
-            <a:r>
-              <a:rPr lang="en-US"/>
-              <a:t>8/18/25</a:t>
-            </a:r>
           </a:p>
         </p:txBody>
       </p:sp>
@@ -28428,34 +27638,6 @@
       </p:sp>
       <p:sp>
         <p:nvSpPr>
-          <p:cNvPr id="2" name="Date Placeholder 1">
-            <a:extLst>
-              <a:ext uri="{FF2B5EF4-FFF2-40B4-BE49-F238E27FC236}">
-                <a16:creationId xmlns:a16="http://schemas.microsoft.com/office/drawing/2014/main" id="{8D48D8DA-2648-62DF-30DE-D7CEFBCD658C}"/>
-              </a:ext>
-            </a:extLst>
-          </p:cNvPr>
-          <p:cNvSpPr>
-            <a:spLocks noGrp="1"/>
-          </p:cNvSpPr>
-          <p:nvPr>
-            <p:ph type="dt" idx="10"/>
-          </p:nvPr>
-        </p:nvSpPr>
-        <p:spPr/>
-        <p:txBody>
-          <a:bodyPr/>
-          <a:lstStyle/>
-          <a:p>
-            <a:r>
-              <a:rPr lang="en-US"/>
-              <a:t>8/18/25</a:t>
-            </a:r>
-          </a:p>
-        </p:txBody>
-      </p:sp>
-      <p:sp>
-        <p:nvSpPr>
           <p:cNvPr id="3" name="Footer Placeholder 2">
             <a:extLst>
               <a:ext uri="{FF2B5EF4-FFF2-40B4-BE49-F238E27FC236}">
@@ -29024,40 +28206,6 @@
           </a:p>
         </p:txBody>
       </p:sp>
-      <p:sp>
-        <p:nvSpPr>
-          <p:cNvPr id="3" name="Date Placeholder 2">
-            <a:extLst>
-              <a:ext uri="{FF2B5EF4-FFF2-40B4-BE49-F238E27FC236}">
-                <a16:creationId xmlns:a16="http://schemas.microsoft.com/office/drawing/2014/main" id="{226AF617-6054-2B25-941A-072D846D4A79}"/>
-              </a:ext>
-            </a:extLst>
-          </p:cNvPr>
-          <p:cNvSpPr>
-            <a:spLocks noGrp="1"/>
-          </p:cNvSpPr>
-          <p:nvPr>
-            <p:ph type="dt" idx="10"/>
-          </p:nvPr>
-        </p:nvSpPr>
-        <p:spPr>
-          <a:xfrm>
-            <a:off x="2931386" y="6356349"/>
-            <a:ext cx="906687" cy="327667"/>
-          </a:xfrm>
-        </p:spPr>
-        <p:txBody>
-          <a:bodyPr/>
-          <a:lstStyle/>
-          <a:p>
-            <a:r>
-              <a:rPr lang="en-US"/>
-              <a:t>8/18/25</a:t>
-            </a:r>
-            <a:endParaRPr lang="en-US" dirty="0"/>
-          </a:p>
-        </p:txBody>
-      </p:sp>
     </p:spTree>
     <p:extLst>
       <p:ext uri="{BB962C8B-B14F-4D97-AF65-F5344CB8AC3E}">
@@ -29689,34 +28837,6 @@
               <a:t>9</a:t>
             </a:fld>
             <a:endParaRPr lang="en-US"/>
-          </a:p>
-        </p:txBody>
-      </p:sp>
-      <p:sp>
-        <p:nvSpPr>
-          <p:cNvPr id="2" name="Date Placeholder 1">
-            <a:extLst>
-              <a:ext uri="{FF2B5EF4-FFF2-40B4-BE49-F238E27FC236}">
-                <a16:creationId xmlns:a16="http://schemas.microsoft.com/office/drawing/2014/main" id="{244C4868-39EA-69A9-2256-9270DD89EDC0}"/>
-              </a:ext>
-            </a:extLst>
-          </p:cNvPr>
-          <p:cNvSpPr>
-            <a:spLocks noGrp="1"/>
-          </p:cNvSpPr>
-          <p:nvPr>
-            <p:ph type="dt" idx="10"/>
-          </p:nvPr>
-        </p:nvSpPr>
-        <p:spPr/>
-        <p:txBody>
-          <a:bodyPr/>
-          <a:lstStyle/>
-          <a:p>
-            <a:r>
-              <a:rPr lang="en-US"/>
-              <a:t>8/18/25</a:t>
-            </a:r>
           </a:p>
         </p:txBody>
       </p:sp>
@@ -30319,15 +29439,6 @@
 </file>
 
 <file path=customXml/item1.xml><?xml version="1.0" encoding="utf-8"?>
-<?mso-contentType ?>
-<FormTemplates xmlns="http://schemas.microsoft.com/sharepoint/v3/contenttype/forms">
-  <Display>DocumentLibraryForm</Display>
-  <Edit>DocumentLibraryForm</Edit>
-  <New>DocumentLibraryForm</New>
-</FormTemplates>
-</file>
-
-<file path=customXml/item2.xml><?xml version="1.0" encoding="utf-8"?>
 <p:properties xmlns:p="http://schemas.microsoft.com/office/2006/metadata/properties" xmlns:xsi="http://www.w3.org/2001/XMLSchema-instance" xmlns:pc="http://schemas.microsoft.com/office/infopath/2007/PartnerControls">
   <documentManagement>
     <TaxCatchAll xmlns="92c16b9d-8c83-445e-a4f4-1fe3d2f43f13" xsi:nil="true"/>
@@ -30338,7 +29449,7 @@
 </p:properties>
 </file>
 
-<file path=customXml/item3.xml><?xml version="1.0" encoding="utf-8"?>
+<file path=customXml/item2.xml><?xml version="1.0" encoding="utf-8"?>
 <ct:contentTypeSchema xmlns:ct="http://schemas.microsoft.com/office/2006/metadata/contentType" xmlns:ma="http://schemas.microsoft.com/office/2006/metadata/properties/metaAttributes" ct:_="" ma:_="" ma:contentTypeName="Document" ma:contentTypeID="0x010100DC7320DB280744439FF1CC777D09ECA4" ma:contentTypeVersion="15" ma:contentTypeDescription="Create a new document." ma:contentTypeScope="" ma:versionID="e50b92032c956cc777cf00ac7d475189">
   <xsd:schema xmlns:xsd="http://www.w3.org/2001/XMLSchema" xmlns:xs="http://www.w3.org/2001/XMLSchema" xmlns:p="http://schemas.microsoft.com/office/2006/metadata/properties" xmlns:ns2="7e49f7d3-8802-46ca-9604-495ce27f67f4" xmlns:ns3="a1519f9a-9d6a-41c1-afc9-552e4069f82f" xmlns:ns4="92c16b9d-8c83-445e-a4f4-1fe3d2f43f13" targetNamespace="http://schemas.microsoft.com/office/2006/metadata/properties" ma:root="true" ma:fieldsID="fcd7cab68a23f1df7b42ced4f3edf141" ns2:_="" ns3:_="" ns4:_="">
     <xsd:import namespace="7e49f7d3-8802-46ca-9604-495ce27f67f4"/>
@@ -30580,15 +29691,16 @@
 </ct:contentTypeSchema>
 </file>
 
-<file path=customXml/itemProps1.xml><?xml version="1.0" encoding="utf-8"?>
-<ds:datastoreItem xmlns:ds="http://schemas.openxmlformats.org/officeDocument/2006/customXml" ds:itemID="{14E7A314-01C0-48C4-8241-85F5E19C1BC9}">
-  <ds:schemaRefs>
-    <ds:schemaRef ds:uri="http://schemas.microsoft.com/sharepoint/v3/contenttype/forms"/>
-  </ds:schemaRefs>
-</ds:datastoreItem>
+<file path=customXml/item3.xml><?xml version="1.0" encoding="utf-8"?>
+<?mso-contentType ?>
+<FormTemplates xmlns="http://schemas.microsoft.com/sharepoint/v3/contenttype/forms">
+  <Display>DocumentLibraryForm</Display>
+  <Edit>DocumentLibraryForm</Edit>
+  <New>DocumentLibraryForm</New>
+</FormTemplates>
 </file>
 
-<file path=customXml/itemProps2.xml><?xml version="1.0" encoding="utf-8"?>
+<file path=customXml/itemProps1.xml><?xml version="1.0" encoding="utf-8"?>
 <ds:datastoreItem xmlns:ds="http://schemas.openxmlformats.org/officeDocument/2006/customXml" ds:itemID="{AF8482CD-4EDA-499F-B4D5-123993B6A2DD}">
   <ds:schemaRefs>
     <ds:schemaRef ds:uri="http://schemas.openxmlformats.org/package/2006/metadata/core-properties"/>
@@ -30606,7 +29718,7 @@
 </ds:datastoreItem>
 </file>
 
-<file path=customXml/itemProps3.xml><?xml version="1.0" encoding="utf-8"?>
+<file path=customXml/itemProps2.xml><?xml version="1.0" encoding="utf-8"?>
 <ds:datastoreItem xmlns:ds="http://schemas.openxmlformats.org/officeDocument/2006/customXml" ds:itemID="{E58E6ED7-70FB-4535-88C7-C9FFFA89B4CB}">
   <ds:schemaRefs>
     <ds:schemaRef ds:uri="http://schemas.microsoft.com/office/2006/metadata/contentType"/>
@@ -30626,6 +29738,14 @@
 </ds:datastoreItem>
 </file>
 
+<file path=customXml/itemProps3.xml><?xml version="1.0" encoding="utf-8"?>
+<ds:datastoreItem xmlns:ds="http://schemas.openxmlformats.org/officeDocument/2006/customXml" ds:itemID="{14E7A314-01C0-48C4-8241-85F5E19C1BC9}">
+  <ds:schemaRefs>
+    <ds:schemaRef ds:uri="http://schemas.microsoft.com/sharepoint/v3/contenttype/forms"/>
+  </ds:schemaRefs>
+</ds:datastoreItem>
+</file>
+
 <file path=docMetadata/LabelInfo.xml><?xml version="1.0" encoding="utf-8"?>
 <clbl:labelList xmlns:clbl="http://schemas.microsoft.com/office/2020/mipLabelMetadata">
   <clbl:label id="{3ded8b1b-070d-4629-82e4-c0b019f46057}" enabled="0" method="" siteId="{3ded8b1b-070d-4629-82e4-c0b019f46057}" removed="1"/>

</xml_diff>